<commit_message>
slide (1,3,4,5) and folder testing img implementation
</commit_message>
<xml_diff>
--- a/reports/Generative_Presentation_Group8.pptx
+++ b/reports/Generative_Presentation_Group8.pptx
@@ -10041,7 +10041,7 @@
                   <a:srgbClr val="FFFFFF"/>
                 </a:solidFill>
               </a:rPr>
-              <a:t>253M</a:t>
+              <a:t>2.2B</a:t>
             </a:r>
             <a:endParaRPr lang="en-US" sz="3600" dirty="0"/>
           </a:p>
@@ -10091,6 +10091,42 @@
                 </a:solidFill>
               </a:rPr>
               <a:t>globally need alt-text</a:t>
+            </a:r>
+          </a:p>
+          <a:p>
+            <a:pPr marL="0" indent="0" algn="ctr">
+              <a:buNone/>
+            </a:pPr>
+            <a:r>
+              <a:rPr lang="en-US" sz="1400" dirty="0">
+                <a:solidFill>
+                  <a:schemeClr val="bg2"/>
+                </a:solidFill>
+              </a:rPr>
+              <a:t>(</a:t>
+            </a:r>
+            <a:r>
+              <a:rPr lang="en-US" sz="1400" dirty="0">
+                <a:solidFill>
+                  <a:schemeClr val="bg2"/>
+                </a:solidFill>
+                <a:hlinkClick r:id="rId3">
+                  <a:extLst>
+                    <a:ext uri="{A12FA001-AC4F-418D-AE19-62706E023703}">
+                      <ahyp:hlinkClr xmlns:ahyp="http://schemas.microsoft.com/office/drawing/2018/hyperlinkcolor" val="tx"/>
+                    </a:ext>
+                  </a:extLst>
+                </a:hlinkClick>
+              </a:rPr>
+              <a:t>WHO, 2026</a:t>
+            </a:r>
+            <a:r>
+              <a:rPr lang="en-US" sz="1400" dirty="0">
+                <a:solidFill>
+                  <a:schemeClr val="bg2"/>
+                </a:solidFill>
+              </a:rPr>
+              <a:t>)</a:t>
             </a:r>
           </a:p>
         </p:txBody>
@@ -10164,7 +10200,7 @@
                   <a:srgbClr val="FFFFFF"/>
                 </a:solidFill>
               </a:rPr>
-              <a:t>2X</a:t>
+              <a:t>10X</a:t>
             </a:r>
             <a:endParaRPr lang="en-US" sz="3600" dirty="0"/>
           </a:p>
@@ -10214,6 +10250,57 @@
                 </a:solidFill>
               </a:rPr>
               <a:t>with auto-generated metadata</a:t>
+            </a:r>
+          </a:p>
+          <a:p>
+            <a:pPr marL="0" indent="0" algn="ctr">
+              <a:buNone/>
+            </a:pPr>
+            <a:r>
+              <a:rPr lang="en-US" sz="1400" dirty="0">
+                <a:solidFill>
+                  <a:schemeClr val="bg2"/>
+                </a:solidFill>
+              </a:rPr>
+              <a:t>(</a:t>
+            </a:r>
+            <a:r>
+              <a:rPr lang="en-US" sz="1400" dirty="0" err="1">
+                <a:solidFill>
+                  <a:schemeClr val="bg2"/>
+                </a:solidFill>
+                <a:hlinkClick r:id="rId4">
+                  <a:extLst>
+                    <a:ext uri="{A12FA001-AC4F-418D-AE19-62706E023703}">
+                      <ahyp:hlinkClr xmlns:ahyp="http://schemas.microsoft.com/office/drawing/2018/hyperlinkcolor" val="tx"/>
+                    </a:ext>
+                  </a:extLst>
+                </a:hlinkClick>
+              </a:rPr>
+              <a:t>MomentsLab</a:t>
+            </a:r>
+            <a:r>
+              <a:rPr lang="en-US" sz="1400" dirty="0">
+                <a:solidFill>
+                  <a:schemeClr val="bg2"/>
+                </a:solidFill>
+                <a:hlinkClick r:id="rId4">
+                  <a:extLst>
+                    <a:ext uri="{A12FA001-AC4F-418D-AE19-62706E023703}">
+                      <ahyp:hlinkClr xmlns:ahyp="http://schemas.microsoft.com/office/drawing/2018/hyperlinkcolor" val="tx"/>
+                    </a:ext>
+                  </a:extLst>
+                </a:hlinkClick>
+              </a:rPr>
+              <a:t>, 2026</a:t>
+            </a:r>
+            <a:r>
+              <a:rPr lang="en-US" sz="1400" dirty="0">
+                <a:solidFill>
+                  <a:schemeClr val="bg2"/>
+                </a:solidFill>
+              </a:rPr>
+              <a:t>)</a:t>
             </a:r>
           </a:p>
         </p:txBody>
@@ -10287,7 +10374,7 @@
                   <a:srgbClr val="FFFFFF"/>
                 </a:solidFill>
               </a:rPr>
-              <a:t>90%</a:t>
+              <a:t>55.5%</a:t>
             </a:r>
             <a:endParaRPr lang="en-US" sz="3600" dirty="0"/>
           </a:p>
@@ -10337,6 +10424,55 @@
                 </a:solidFill>
               </a:rPr>
               <a:t>accessible descriptions</a:t>
+            </a:r>
+          </a:p>
+          <a:p>
+            <a:pPr algn="ctr"/>
+            <a:r>
+              <a:rPr lang="en-US" sz="1400" dirty="0">
+                <a:solidFill>
+                  <a:schemeClr val="bg2"/>
+                </a:solidFill>
+              </a:rPr>
+              <a:t>(</a:t>
+            </a:r>
+            <a:r>
+              <a:rPr lang="en-US" sz="1400" dirty="0" err="1">
+                <a:solidFill>
+                  <a:schemeClr val="bg2"/>
+                </a:solidFill>
+                <a:hlinkClick r:id="rId5">
+                  <a:extLst>
+                    <a:ext uri="{A12FA001-AC4F-418D-AE19-62706E023703}">
+                      <ahyp:hlinkClr xmlns:ahyp="http://schemas.microsoft.com/office/drawing/2018/hyperlinkcolor" val="tx"/>
+                    </a:ext>
+                  </a:extLst>
+                </a:hlinkClick>
+              </a:rPr>
+              <a:t>wearetenet</a:t>
+            </a:r>
+            <a:r>
+              <a:rPr lang="en-US" sz="1400" dirty="0">
+                <a:solidFill>
+                  <a:schemeClr val="bg2"/>
+                </a:solidFill>
+                <a:hlinkClick r:id="rId5">
+                  <a:extLst>
+                    <a:ext uri="{A12FA001-AC4F-418D-AE19-62706E023703}">
+                      <ahyp:hlinkClr xmlns:ahyp="http://schemas.microsoft.com/office/drawing/2018/hyperlinkcolor" val="tx"/>
+                    </a:ext>
+                  </a:extLst>
+                </a:hlinkClick>
+              </a:rPr>
+              <a:t>, 2026</a:t>
+            </a:r>
+            <a:r>
+              <a:rPr lang="en-US" sz="1400" dirty="0">
+                <a:solidFill>
+                  <a:schemeClr val="bg2"/>
+                </a:solidFill>
+              </a:rPr>
+              <a:t>)</a:t>
             </a:r>
           </a:p>
         </p:txBody>
@@ -11533,8 +11669,8 @@
         </p:nvSpPr>
         <p:spPr>
           <a:xfrm>
-            <a:off x="5728716" y="1042416"/>
-            <a:ext cx="914400" cy="201168"/>
+            <a:off x="5340096" y="1012286"/>
+            <a:ext cx="1816658" cy="201168"/>
           </a:xfrm>
           <a:prstGeom prst="rect">
             <a:avLst/>
@@ -11555,7 +11691,7 @@
                   <a:srgbClr val="0B6E4F"/>
                 </a:solidFill>
               </a:rPr>
-              <a:t>50 tokens</a:t>
+              <a:t>Dynamic tokens + sentences</a:t>
             </a:r>
             <a:endParaRPr lang="en-US" sz="1200" dirty="0"/>
           </a:p>
@@ -12630,7 +12766,7 @@
                   <a:srgbClr val="0D1B2A"/>
                 </a:solidFill>
               </a:rPr>
-              <a:t>0.6 M trainable</a:t>
+              <a:t>62.9M params</a:t>
             </a:r>
             <a:endParaRPr lang="en-US" sz="1400" dirty="0"/>
           </a:p>
@@ -12961,16 +13097,14 @@
           <a:bodyPr wrap="square" lIns="0" tIns="0" rIns="0" bIns="0" rtlCol="0" anchor="ctr"/>
           <a:lstStyle/>
           <a:p>
-            <a:pPr marL="0" indent="0" algn="ctr">
-              <a:buNone/>
-            </a:pPr>
+            <a:pPr algn="ctr"/>
             <a:r>
               <a:rPr lang="en-US" sz="1400" b="1" dirty="0">
                 <a:solidFill>
                   <a:srgbClr val="0B6E4F"/>
                 </a:solidFill>
               </a:rPr>
-              <a:t>67.6 M trainable</a:t>
+              <a:t>129.9M params</a:t>
             </a:r>
             <a:endParaRPr lang="en-US" sz="1400" dirty="0"/>
           </a:p>
@@ -13312,7 +13446,7 @@
                   <a:srgbClr val="E85D04"/>
                 </a:solidFill>
               </a:rPr>
-              <a:t>0.8 M trainable</a:t>
+              <a:t>63.76M params</a:t>
             </a:r>
             <a:endParaRPr lang="en-US" sz="1400" dirty="0"/>
           </a:p>
@@ -15556,7 +15690,7 @@
         <p:spPr>
           <a:xfrm>
             <a:off x="1470580" y="1239570"/>
-            <a:ext cx="6759019" cy="3379510"/>
+            <a:ext cx="6759019" cy="3100082"/>
           </a:xfrm>
           <a:prstGeom prst="rect">
             <a:avLst/>

</xml_diff>